<commit_message>
Speed up all tasks from 101 s to 45 s, results unchanged
pyarrow parses the export, a small month arithmetic replaces dateutil in
the monthly loops, the statement reads plain lists, and the units of every
position are kept by date for valuations. Every result of t0-t5 and t7 is
identical to the previous version. Report, deck and README updated.

Co-Authored-By: Claude Opus 5.5 <noreply@anthropic.com>
</commit_message>
<xml_diff>
--- a/presentation/NAMA_Neuron_Migration.pptx
+++ b/presentation/NAMA_Neuron_Migration.pptx
@@ -115,39 +115,39 @@
   <p:extLst>
     <p:ext uri="{521415D9-36F7-43E2-AB2F-B90AF26B5E84}">
       <p14:sectionLst xmlns:p14="http://schemas.microsoft.com/office/powerpoint/2010/main">
-        <p14:section name="Opening" id="{aae4dac2-8ed3-9026-60b3-7bb60386cf5e}">
+        <p14:section name="Opening" id="{3f626b96-4d11-cc63-1602-ea435b6531c1}">
           <p14:sldIdLst>
             <p14:sldId id="256"/>
           </p14:sldIdLst>
         </p14:section>
-        <p14:section name="Challenge" id="{8c3d9848-859e-880b-3418-1e8c948b420e}">
+        <p14:section name="Challenge" id="{e251a27d-4f43-dc54-6ec2-92de50313fbb}">
           <p14:sldIdLst>
             <p14:sldId id="257"/>
           </p14:sldIdLst>
         </p14:section>
-        <p14:section name="Approach" id="{245c643e-3f8a-993c-edc6-2e5b7f889e3a}">
+        <p14:section name="Approach" id="{0ea8c6a0-81a8-c840-e2d9-a8dae33b7d81}">
           <p14:sldIdLst>
             <p14:sldId id="258"/>
             <p14:sldId id="259"/>
           </p14:sldIdLst>
         </p14:section>
-        <p14:section name="Findings" id="{54e42b02-b2d8-5fbf-cf6e-8519d6f736dd}">
+        <p14:section name="Findings" id="{fca44ad8-39a9-243e-5647-b35f0ea43597}">
           <p14:sldIdLst>
             <p14:sldId id="260"/>
             <p14:sldId id="261"/>
           </p14:sldIdLst>
         </p14:section>
-        <p14:section name="Results" id="{66ba80b2-c1fd-9ea9-dc8d-15c2c147a123}">
+        <p14:section name="Results" id="{2d34e5bc-40f3-80ee-7c20-34ad29774900}">
           <p14:sldIdLst>
             <p14:sldId id="262"/>
           </p14:sldIdLst>
         </p14:section>
-        <p14:section name="Surprise t7" id="{19caedcc-eca2-ea85-e4f8-f6fb7ff4188f}">
+        <p14:section name="Surprise t7" id="{a1b06c9e-d9a4-8e3d-4091-5725da13b88d}">
           <p14:sldIdLst>
             <p14:sldId id="263"/>
           </p14:sldIdLst>
         </p14:section>
-        <p14:section name="Closing" id="{d1923791-4055-7923-e670-0a52926d3a0b}">
+        <p14:section name="Closing" id="{081863fa-1d66-4587-fec0-697381bad94b}">
           <p14:sldIdLst>
             <p14:sldId id="264"/>
           </p14:sldIdLst>
@@ -1079,7 +1079,7 @@
             <c:size val="6"/>
             <c:spPr>
               <a:solidFill>
-                <a:srgbClr val="D52B1E"/>
+                <a:srgbClr val="F4A259"/>
               </a:solidFill>
               <a:ln w="9525" cap="flat">
                 <a:solidFill>
@@ -2424,7 +2424,7 @@
           <a:p>
             <a:r>
               <a:rPr lang="en-US" dirty="0"/>
-              <a:t>With these rules we reach between 99.7 and 100 percent on every task. For surrender values and statements we recalculate the whole fund accounting ourselves, more than five million bookings, and every one of them matches Neuron except three that were changed by hand. In fact, every remaining difference is a manual correction, and our outlier detection for task five finds them automatically: 55 values, including all 38 from the official list and 17 that nobody had listed. Tasks zero to five run in about a minute and a half, with one small module per task.</a:t>
+              <a:t>With these rules we reach between 99.7 and 100 percent on every task. For surrender values and statements we recalculate the whole fund accounting ourselves, more than five million bookings, and every one of them matches Neuron except three that were changed by hand. In fact, every remaining difference is a manual correction, and our outlier detection for task five finds them automatically: 55 values, including all 38 from the official list and 17 that nobody had listed. Tasks zero to five run in about 45 seconds, with one small module per task.</a:t>
             </a:r>
             <a:endParaRPr lang="en-US" dirty="0"/>
           </a:p>
@@ -8492,7 +8492,7 @@
                   <a:schemeClr val="accent4"/>
                 </a:solidFill>
               </a:rPr>
-              <a:t>Train set, official scoring  ·  t0–t5 run in 1.5 minutes  ·  maintainability index 68</a:t>
+              <a:t>Train set, official scoring  ·  t0–t5 run in 45 seconds  ·  maintainability index 68</a:t>
             </a:r>
             <a:endParaRPr lang="en-US" sz="1100" dirty="0"/>
           </a:p>

</xml_diff>